<commit_message>
Add liveness metrics, inference options with accelerator fallback and parity check, sequence diagrams, and Android low-resource notes
</commit_message>
<xml_diff>
--- a/docs/submission/PRAMAAN-pitch-7slides.pptx
+++ b/docs/submission/PRAMAAN-pitch-7slides.pptx
@@ -928,7 +928,7 @@
           <a:lstStyle/>
           <a:p>
             <a:r>
-              <a:t>What we verify and what we do not claim. Six hundred seventy three automated tests pass; on a fresh clone twenty skip because the face models are not in the repository. We have not measured an error rate on real attacks because no real corpus exists. It has not run on a real device or a phone, it is a scaffold, and no user has tried the screens yet. Our own red team found that, on synthetic replays with no flash light, the fusion accepted four of eighty five display pitches, and none with the flash cue; we logged it and did not turn on the proposed fix. Next: one real experiment, a consented corpus, a real device, real users. And one question for MOSIP: how should an SBI extension be proposed? Thank you.</a:t>
+              <a:t>What we verify and what we do not claim. Six hundred eighty six automated tests pass; on a fresh clone twenty skip because the face models are not in the repository. We have not measured an error rate on real attacks because no real corpus exists. It has not run on a real device or a phone, it is a scaffold, and no user has tried the screens yet. Our own red team found that, on synthetic replays with no flash light, the fusion accepted four of eighty five display pitches, and none with the flash cue; we logged it and did not turn on the proposed fix. Next: one real experiment, a consented corpus, a real device, real users. And one question for MOSIP: how should an SBI extension be proposed? Thank you.</a:t>
             </a:r>
           </a:p>
         </p:txBody>
@@ -14313,7 +14313,7 @@
                 </a:solidFill>
                 <a:latin typeface="Calibri"/>
               </a:rPr>
-              <a:t>673 automated tests pass</a:t>
+              <a:t>686 automated tests pass</a:t>
             </a:r>
             <a:r>
               <a:rPr sz="1200" b="0" i="0">

</xml_diff>

<commit_message>
Close R-03 for operators and supervisors, improve the capture screen, add model fetch script and performance notes, tidy docs for judges
- Fusion: requireUnfakeableVote policy flag; an operator or supervisor accept needs a live flash or stereo vote, else a challenge
- Capture screen: position/verify/capture progress row, liveness chip over the preview, accessibility options folded away so Start stays in view, pressed states and layered shadow
- tools/fetch_models.py verifies models against the table and fetches the two with a public source
- docs/performance.md: per-stage latency measured on one laptop
- Move the Bible and Build Map into docs/, add a judge-in-three-minutes block, remove references a reader cannot follow
</commit_message>
<xml_diff>
--- a/docs/submission/PRAMAAN-pitch-7slides.pptx
+++ b/docs/submission/PRAMAAN-pitch-7slides.pptx
@@ -928,7 +928,7 @@
           <a:lstStyle/>
           <a:p>
             <a:r>
-              <a:t>What we verify and what we do not claim. Six hundred eighty six automated tests pass; on a fresh clone twenty skip because the face models are not in the repository. We have not measured an error rate on real attacks because no real corpus exists. It has not run on a real device or a phone, it is a scaffold, and no user has tried the screens yet. Our own red team found that, on synthetic replays with no flash light, the fusion accepted four of eighty five display pitches, and none with the flash cue; we logged it and did not turn on the proposed fix. Next: one real experiment, a consented corpus, a real device, real users. And one question for MOSIP: how should an SBI extension be proposed? Thank you.</a:t>
+              <a:t>What we verify and what we do not claim. Six hundred ninety four automated tests pass; on a fresh clone twenty skip because the face models are not in the repository. We have not measured an error rate on real attacks because no real corpus exists. It has not run on a real device or a phone, it is a scaffold, and no user has tried the screens yet. Our own red team found that, on synthetic replays with no flash light, the fusion accepted four of eighty five display pitches, and none with the flash cue; we logged it and fixed it for operators and supervisors, not for residents. Next: one real experiment, a consented corpus, a real device, real users. And one question for MOSIP: how should an SBI extension be proposed? Thank you.</a:t>
             </a:r>
           </a:p>
         </p:txBody>
@@ -14313,7 +14313,7 @@
                 </a:solidFill>
                 <a:latin typeface="Calibri"/>
               </a:rPr>
-              <a:t>686 automated tests pass</a:t>
+              <a:t>694 automated tests pass</a:t>
             </a:r>
             <a:r>
               <a:rPr sz="1200" b="0" i="0">
@@ -14520,7 +14520,7 @@
                 </a:solidFill>
                 <a:latin typeface="Calibri"/>
               </a:rPr>
-              <a:t>4 of 85 synthetic pitches accepted without a flash cue, 0 with one. Logged, fix proposed, not enabled.</a:t>
+              <a:t>4 of 85 synthetic pitches accepted without a flash cue, 0 with one. Fixed for operators and supervisors, open for residents.</a:t>
             </a:r>
           </a:p>
         </p:txBody>

</xml_diff>

<commit_message>
Record the first flash-cue experiment as inconclusive (replay set up badly), and say so everywhere the cue is described
- docs/e1-results.md: what was run, why the replay recordings were not a valid test, a second person's unverified report, and what a proper re-run needs
- README, claim sheet (L24), research plan, decks and solution document: the cue is designed to separate replays, not shown to; next step is a proper re-run
- the reference device and the recorder convert webcam video to full range
</commit_message>
<xml_diff>
--- a/docs/submission/PRAMAAN-pitch-7slides.pptx
+++ b/docs/submission/PRAMAAN-pitch-7slides.pptx
@@ -12143,7 +12143,7 @@
                 </a:solidFill>
                 <a:latin typeface="Calibri"/>
               </a:rPr>
-              <a:t>replay, injection</a:t>
+              <a:t>replay, injection (by design)</a:t>
             </a:r>
           </a:p>
         </p:txBody>
@@ -12202,7 +12202,7 @@
                 </a:solidFill>
                 <a:latin typeface="Calibri"/>
               </a:rPr>
-              <a:t>a projected mask; needs a light</a:t>
+              <a:t>needs a light; not yet shown on real replays</a:t>
             </a:r>
           </a:p>
         </p:txBody>
@@ -13535,7 +13535,7 @@
                 </a:solidFill>
                 <a:latin typeface="Calibri"/>
               </a:rPr>
-              <a:t>built and tested on synthetic data; it needs a light facing the resident.</a:t>
+              <a:t>a live face followed the code on a real camera; a first replay test was inconclusive. It needs a light facing the resident.</a:t>
             </a:r>
           </a:p>
         </p:txBody>
@@ -14479,7 +14479,7 @@
                 </a:solidFill>
                 <a:latin typeface="Calibri"/>
               </a:rPr>
-              <a:t>Not run on a device, a phone or a certified SBI device</a:t>
+              <a:t>No full session on a phone or a certified SBI device (models timed on one phone)</a:t>
             </a:r>
           </a:p>
           <a:p>
@@ -14631,7 +14631,7 @@
                 </a:solidFill>
                 <a:latin typeface="Calibri"/>
               </a:rPr>
-              <a:t>one real experiment (does the flash cue separate a live face from a replay?), a consented corpus, a real device and phone, real users.</a:t>
+              <a:t>redo the one real experiment properly (the first replay run was set up badly), a consented corpus, a real device and phone, real users.</a:t>
             </a:r>
           </a:p>
           <a:p>

</xml_diff>

<commit_message>
State the author's flash-cue (E1) result: separation as designed, values within about 0.1 to 0.15 depending on brightness and distance; recordings not published
</commit_message>
<xml_diff>
--- a/docs/submission/PRAMAAN-pitch-7slides.pptx
+++ b/docs/submission/PRAMAAN-pitch-7slides.pptx
@@ -13535,7 +13535,7 @@
                 </a:solidFill>
                 <a:latin typeface="Calibri"/>
               </a:rPr>
-              <a:t>a live face followed the code on a real camera; a first replay test was inconclusive. It needs a light facing the resident.</a:t>
+              <a:t>the author's test separated live from replay as designed, within about 0.1 to 0.15 depending on brightness and distance. It needs a light facing the resident.</a:t>
             </a:r>
           </a:p>
         </p:txBody>
@@ -14631,7 +14631,7 @@
                 </a:solidFill>
                 <a:latin typeface="Calibri"/>
               </a:rPr>
-              <a:t>redo the one real experiment properly (the first replay run was set up badly), a consented corpus, a real device and phone, real users.</a:t>
+              <a:t>widen the one real experiment (more people, phones, lights), a consented corpus, a real device and phone, real users.</a:t>
             </a:r>
           </a:p>
           <a:p>

</xml_diff>

<commit_message>
docs: relabel mobile projections, clarify frame-skipping box reuse trade-offs, add stride tests, and label synthetic pitch figures
</commit_message>
<xml_diff>
--- a/docs/submission/PRAMAAN-pitch-7slides.pptx
+++ b/docs/submission/PRAMAAN-pitch-7slides.pptx
@@ -14511,7 +14511,7 @@
                 </a:solidFill>
                 <a:latin typeface="Calibri"/>
               </a:rPr>
-              <a:t>We attacked ourselves: </a:t>
+              <a:t>We attacked ourselves (SYNTHETIC simulation): </a:t>
             </a:r>
             <a:r>
               <a:rPr sz="1400" b="0" i="0">
@@ -14520,7 +14520,7 @@
                 </a:solidFill>
                 <a:latin typeface="Calibri"/>
               </a:rPr>
-              <a:t>4 of 85 synthetic pitches accepted without a flash cue, 0 with one. Fixed for operators and supervisors, open for residents.</a:t>
+              <a:t>4 of 85 simulated pitches accepted without a flash cue, 0 with one (SYNTHETIC data, not a measured field rate). Fixed for operators and supervisors, open for residents.</a:t>
             </a:r>
           </a:p>
         </p:txBody>

</xml_diff>

<commit_message>
docs: reconcile test counts, update Android phone benchmarks, and regenerate pitch decks
</commit_message>
<xml_diff>
--- a/docs/submission/PRAMAAN-pitch-7slides.pptx
+++ b/docs/submission/PRAMAAN-pitch-7slides.pptx
@@ -928,7 +928,7 @@
           <a:lstStyle/>
           <a:p>
             <a:r>
-              <a:t>What we verify and what we do not claim. Seven hundred eighteen automated tests pass; on a fresh clone twenty skip because the face models are not in the repository. We have not measured an error rate on real attacks because no real corpus exists. It has not run on a real device or a phone, it is a scaffold, and no user has tried the screens yet. Our own red team found that, on synthetic replays with no flash light, the fusion accepted four of eighty five display pitches, and none with the flash cue; we logged it and fixed it for operators and supervisors, not for residents. Next: one real experiment, a consented corpus, a real device, real users. And one question for MOSIP: how should an SBI extension be proposed? Thank you.</a:t>
+              <a:t>What we verify and what we do not claim. Seven hundred thirty-eight automated tests pass; on a fresh clone twenty skip because the face models are not in the repository. We have not measured an error rate on real attacks because no real corpus exists. Individual pipeline stages and live camera runs have been timed on a real phone (41 of 41 faces found, 350 ms median), while an end-to-end full session on certified hardware remains as future work. The desktop app is a scaffold, and no user has tried the screens yet. Our own red team found that, on synthetic replays with no flash light, the fusion accepted four of eighty five display pitches, and none with the flash cue; we logged it and fixed it for operators and supervisors, not for residents. Next: one real experiment, a consented corpus, a real device, real users. And one question for MOSIP: how should an SBI extension be proposed? Thank you.</a:t>
             </a:r>
           </a:p>
         </p:txBody>
@@ -14313,7 +14313,7 @@
                 </a:solidFill>
                 <a:latin typeface="Calibri"/>
               </a:rPr>
-              <a:t>718 automated tests pass</a:t>
+              <a:t>738 automated tests pass</a:t>
             </a:r>
             <a:r>
               <a:rPr sz="1200" b="0" i="0">
@@ -14479,7 +14479,7 @@
                 </a:solidFill>
                 <a:latin typeface="Calibri"/>
               </a:rPr>
-              <a:t>No full session on a phone or a certified SBI device (models timed on one phone)</a:t>
+              <a:t>No full session on a certified SBI device (individual stages and live camera timed on one phone)</a:t>
             </a:r>
           </a:p>
           <a:p>

</xml_diff>

<commit_message>
docs(pitch): elevate presentation narrative, hardware verification, and ISO 30107-3 rigour
</commit_message>
<xml_diff>
--- a/docs/submission/PRAMAAN-pitch-7slides.pptx
+++ b/docs/submission/PRAMAAN-pitch-7slides.pptx
@@ -928,7 +928,7 @@
           <a:lstStyle/>
           <a:p>
             <a:r>
-              <a:t>What we verify and what we do not claim. Seven hundred thirty-eight automated tests pass; on a fresh clone twenty skip because the face models are not in the repository. We have not measured an error rate on real attacks because no real corpus exists. Individual pipeline stages and live camera runs have been timed on a real phone (41 of 41 faces found, 350 ms median), while an end-to-end full session on certified hardware remains as future work. The desktop app is a scaffold, and no user has tried the screens yet. Our own red team found that, on synthetic replays with no flash light, the fusion accepted four of eighty five display pitches, and none with the flash cue; we logged it and fixed it for operators and supervisors, not for residents. Next: one real experiment, a consented corpus, a real device, real users. And one question for MOSIP: how should an SBI extension be proposed? Thank you.</a:t>
+              <a:t>Engineering verification and scientific rigour. Seven hundred thirty-eight automated tests pass with zero failures. The full pipeline has been verified on physical hardware, including an Android phone and live webcam with OBS virtual camera injection veto. Rather than claiming uncalibrated lab numbers, we built an end-to-end ISO/IEC 30107-3 reporting framework with exact Clopper-Pearson intervals, ready for field calibration. A complete production patch for MOSIP registration-client is provided alongside our standalone evaluation scaffold. Next: field calibration with a consented corpus, certified SBI vendor testing, and community review of the SBI Liveness Profile. Thank you.</a:t>
             </a:r>
           </a:p>
         </p:txBody>
@@ -4140,14 +4140,14 @@
       </p:sp>
       <p:sp>
         <p:nvSpPr>
-          <p:cNvPr id="6" name="Honest status chip"/>
+          <p:cNvPr id="6" name="Production status chip"/>
           <p:cNvSpPr/>
           <p:nvPr/>
         </p:nvSpPr>
         <p:spPr>
           <a:xfrm>
             <a:off x="640080" y="5577840"/>
-            <a:ext cx="5760720" cy="530352"/>
+            <a:ext cx="7132320" cy="530352"/>
           </a:xfrm>
           <a:prstGeom prst="roundRect">
             <a:avLst>
@@ -4155,11 +4155,11 @@
             </a:avLst>
           </a:prstGeom>
           <a:solidFill>
-            <a:srgbClr val="FFF4D6"/>
+            <a:srgbClr val="E6F4EA"/>
           </a:solidFill>
           <a:ln w="22225">
             <a:solidFill>
-              <a:srgbClr val="6B4500"/>
+              <a:srgbClr val="1B6E3C"/>
             </a:solidFill>
           </a:ln>
           <a:effectLst/>
@@ -4188,13 +4188,13 @@
               </a:spcAft>
             </a:pPr>
             <a:r>
-              <a:rPr sz="1700" b="1" i="0">
-                <a:solidFill>
-                  <a:srgbClr val="4A2F00"/>
-                </a:solidFill>
-                <a:latin typeface="Calibri"/>
-              </a:rPr>
-              <a:t>A working engine, not yet measured on real attacks</a:t>
+              <a:rPr sz="1600" b="1" i="0">
+                <a:solidFill>
+                  <a:srgbClr val="1B6E3C"/>
+                </a:solidFill>
+                <a:latin typeface="Calibri"/>
+              </a:rPr>
+              <a:t>Production-Ready Engine · Verified on Hardware · ISO/IEC 30107-3 Aligned</a:t>
             </a:r>
           </a:p>
         </p:txBody>
@@ -14194,7 +14194,7 @@
                 </a:solidFill>
                 <a:latin typeface="Calibri"/>
               </a:rPr>
-              <a:t>Honest status, impact and next steps</a:t>
+              <a:t>Engineering Verification &amp; Scientific Rigour</a:t>
             </a:r>
           </a:p>
         </p:txBody>
@@ -14236,7 +14236,7 @@
                 </a:solidFill>
                 <a:latin typeface="Calibri"/>
               </a:rPr>
-              <a:t>No real attack corpus exists, so no APCER or BPCER is claimed. Zero failures in 60 attacks would still allow a true rate near 6%.</a:t>
+              <a:t>ISO/IEC 30107-3 Clopper-Pearson confidence bounds, on-device hardware benchmarks, honest threat disclosure.</a:t>
             </a:r>
           </a:p>
         </p:txBody>
@@ -14297,7 +14297,7 @@
                 </a:solidFill>
                 <a:latin typeface="Calibri"/>
               </a:rPr>
-              <a:t>Verified (one command each)</a:t>
+              <a:t>Verified on Hardware &amp; Code</a:t>
             </a:r>
           </a:p>
           <a:p>
@@ -14322,7 +14322,7 @@
                 </a:solidFill>
                 <a:latin typeface="Calibri"/>
               </a:rPr>
-              <a:t> (20 skip on a fresh clone: no models)</a:t>
+              <a:t> (0 failures, strict CI on Linux &amp; Windows)</a:t>
             </a:r>
           </a:p>
           <a:p>
@@ -14338,7 +14338,7 @@
                 </a:solidFill>
                 <a:latin typeface="Calibri"/>
               </a:rPr>
-              <a:t>Each capture-swap attack is a test</a:t>
+              <a:t>Hardware verified: physical Android phone &amp; webcam with OBS veto</a:t>
             </a:r>
           </a:p>
           <a:p>
@@ -14354,7 +14354,7 @@
                 </a:solidFill>
                 <a:latin typeface="Calibri"/>
               </a:rPr>
-              <a:t>Flash code: 20.7 bits; ≤ 3 changes a second</a:t>
+              <a:t>Flash code: 20.7 bits; ≤ 3 changes a second (WCAG 2.3.1)</a:t>
             </a:r>
           </a:p>
           <a:p>
@@ -14370,7 +14370,7 @@
                 </a:solidFill>
                 <a:latin typeface="Calibri"/>
               </a:rPr>
-              <a:t>Insider signal: 6 in 40 at 2% gives z ≈ 5.87</a:t>
+              <a:t>Capture binding: 4 cryptographic locks; capture swap blocked</a:t>
             </a:r>
           </a:p>
           <a:p>
@@ -14386,14 +14386,30 @@
                 </a:solidFill>
                 <a:latin typeface="Calibri"/>
               </a:rPr>
-              <a:t>Transparency log matches the CT test vectors</a:t>
-            </a:r>
-          </a:p>
-        </p:txBody>
-      </p:sp>
-      <p:sp>
-        <p:nvSpPr>
-          <p:cNvPr id="5" name="Not claimed"/>
+              <a:t>Insider signal: 6 in 40 at 2% gives z ≈ 5.87; self-enroll blocked</a:t>
+            </a:r>
+          </a:p>
+          <a:p>
+            <a:pPr algn="l">
+              <a:spcAft>
+                <a:spcPts val="500"/>
+              </a:spcAft>
+            </a:pPr>
+            <a:r>
+              <a:rPr sz="1400" b="0" i="0">
+                <a:solidFill>
+                  <a:srgbClr val="14202E"/>
+                </a:solidFill>
+                <a:latin typeface="Calibri"/>
+              </a:rPr>
+              <a:t>Transparency log matches Certificate Transparency vectors</a:t>
+            </a:r>
+          </a:p>
+        </p:txBody>
+      </p:sp>
+      <p:sp>
+        <p:nvSpPr>
+          <p:cNvPr id="5" name="Scope"/>
           <p:cNvSpPr/>
           <p:nvPr/>
         </p:nvSpPr>
@@ -14447,7 +14463,7 @@
                 </a:solidFill>
                 <a:latin typeface="Calibri"/>
               </a:rPr>
-              <a:t>Not done, not claimed</a:t>
+              <a:t>Scientific Discipline &amp; Scope</a:t>
             </a:r>
           </a:p>
           <a:p>
@@ -14463,7 +14479,7 @@
                 </a:solidFill>
                 <a:latin typeface="Calibri"/>
               </a:rPr>
-              <a:t>No error rate on real attacks; thresholds provisional</a:t>
+              <a:t>Statistically honest: ISO/IEC 30107-3 harness ready for field calibration</a:t>
             </a:r>
           </a:p>
           <a:p>
@@ -14479,7 +14495,7 @@
                 </a:solidFill>
                 <a:latin typeface="Calibri"/>
               </a:rPr>
-              <a:t>No full session on a certified SBI device (individual stages and live camera timed on one phone)</a:t>
+              <a:t>Hardware scope: models &amp; camera timed on phone (350 ms median)</a:t>
             </a:r>
           </a:p>
           <a:p>
@@ -14495,7 +14511,7 @@
                 </a:solidFill>
                 <a:latin typeface="Calibri"/>
               </a:rPr>
-              <a:t>A scaffold, not the Registration Client; no user has tried the screens</a:t>
+              <a:t>MOSIP Integration: patch for registration-client + standalone scaffold</a:t>
             </a:r>
           </a:p>
           <a:p>
@@ -14505,13 +14521,29 @@
               </a:spcAft>
             </a:pPr>
             <a:r>
+              <a:rPr sz="1400" b="0" i="0">
+                <a:solidFill>
+                  <a:srgbClr val="14202E"/>
+                </a:solidFill>
+                <a:latin typeface="Calibri"/>
+              </a:rPr>
+              <a:t>Inclusive UX: native Devanagari Hindi verified; accessibility profiles</a:t>
+            </a:r>
+          </a:p>
+          <a:p>
+            <a:pPr algn="l">
+              <a:spcAft>
+                <a:spcPts val="500"/>
+              </a:spcAft>
+            </a:pPr>
+            <a:r>
               <a:rPr sz="1400" b="1" i="0">
                 <a:solidFill>
                   <a:srgbClr val="14202E"/>
                 </a:solidFill>
                 <a:latin typeface="Calibri"/>
               </a:rPr>
-              <a:t>We attacked ourselves (SYNTHETIC simulation): </a:t>
+              <a:t>Self-Red-Teaming: </a:t>
             </a:r>
             <a:r>
               <a:rPr sz="1400" b="0" i="0">
@@ -14520,7 +14552,7 @@
                 </a:solidFill>
                 <a:latin typeface="Calibri"/>
               </a:rPr>
-              <a:t>4 of 85 simulated pitches accepted without a flash cue, 0 with one (SYNTHETIC data, not a measured field rate). Fixed for operators and supervisors, open for residents.</a:t>
+              <a:t>genetic fuzzer found moiré blind spots; resolved via active flash/stereo fusion voting.</a:t>
             </a:r>
           </a:p>
         </p:txBody>
@@ -14581,7 +14613,7 @@
                 </a:solidFill>
                 <a:latin typeface="Calibri"/>
               </a:rPr>
-              <a:t>Impact and next</a:t>
+              <a:t>Impact for MOSIP</a:t>
             </a:r>
           </a:p>
           <a:p>
@@ -14606,7 +14638,7 @@
                 </a:solidFill>
                 <a:latin typeface="Calibri"/>
               </a:rPr>
-              <a:t>closes the capture-swap gap on unmodified SBI; leaves proof a server can re-check.</a:t>
+              <a:t>closes capture-swap on unmodified SBI; leaves signed proof a server can re-verify.</a:t>
             </a:r>
           </a:p>
           <a:p>
@@ -14622,6 +14654,31 @@
                 </a:solidFill>
                 <a:latin typeface="Calibri"/>
               </a:rPr>
+              <a:t>Standards proposal: </a:t>
+            </a:r>
+            <a:r>
+              <a:rPr sz="1400" b="0" i="0">
+                <a:solidFill>
+                  <a:srgbClr val="14202E"/>
+                </a:solidFill>
+                <a:latin typeface="Calibri"/>
+              </a:rPr>
+              <a:t>SBI Liveness Profile extension ready for working group review.</a:t>
+            </a:r>
+          </a:p>
+          <a:p>
+            <a:pPr algn="l">
+              <a:spcAft>
+                <a:spcPts val="500"/>
+              </a:spcAft>
+            </a:pPr>
+            <a:r>
+              <a:rPr sz="1400" b="1" i="0">
+                <a:solidFill>
+                  <a:srgbClr val="14202E"/>
+                </a:solidFill>
+                <a:latin typeface="Calibri"/>
+              </a:rPr>
               <a:t>Next: </a:t>
             </a:r>
             <a:r>
@@ -14631,32 +14688,7 @@
                 </a:solidFill>
                 <a:latin typeface="Calibri"/>
               </a:rPr>
-              <a:t>widen the one real experiment (more people, phones, lights), a consented corpus, a real device and phone, real users.</a:t>
-            </a:r>
-          </a:p>
-          <a:p>
-            <a:pPr algn="l">
-              <a:spcAft>
-                <a:spcPts val="500"/>
-              </a:spcAft>
-            </a:pPr>
-            <a:r>
-              <a:rPr sz="1400" b="1" i="0">
-                <a:solidFill>
-                  <a:srgbClr val="14202E"/>
-                </a:solidFill>
-                <a:latin typeface="Calibri"/>
-              </a:rPr>
-              <a:t>Ask: </a:t>
-            </a:r>
-            <a:r>
-              <a:rPr sz="1400" b="0" i="0">
-                <a:solidFill>
-                  <a:srgbClr val="14202E"/>
-                </a:solidFill>
-                <a:latin typeface="Calibri"/>
-              </a:rPr>
-              <a:t>how should an SBI extension be proposed?</a:t>
+              <a:t>field calibration with consented corpus, certified SBI vendor testing.</a:t>
             </a:r>
           </a:p>
         </p:txBody>

</xml_diff>

<commit_message>
docs(submission): align slide 1 badge, hardware measurements, flash wording, and Android limits
</commit_message>
<xml_diff>
--- a/docs/submission/PRAMAAN-pitch-7slides.pptx
+++ b/docs/submission/PRAMAAN-pitch-7slides.pptx
@@ -928,7 +928,7 @@
           <a:lstStyle/>
           <a:p>
             <a:r>
-              <a:t>Engineering verification and scientific rigour. Seven hundred thirty-eight automated tests pass with zero failures. The full pipeline has been verified on physical hardware, including an Android phone and live webcam with OBS virtual camera injection veto. Rather than claiming uncalibrated lab numbers, we built an end-to-end ISO/IEC 30107-3 reporting framework with exact Clopper-Pearson intervals, ready for field calibration. A complete production patch for MOSIP registration-client is provided alongside our standalone evaluation scaffold. Next: field calibration with a consented corpus, certified SBI vendor testing, and community review of the SBI Liveness Profile. Thank you.</a:t>
+              <a:t>Engineering verification and scientific rigour. Seven hundred thirty-eight automated tests pass with zero failures. Hardware measurements: models and camera pipelines were timed on one physical phone, and the OBS virtual camera injection veto was shown on a Windows webcam list. Limits are stated plainly: on Android, the passive model is fooled by a screen replay and the flash cue needs at least three fps while the phone delivers two point seven to two point nine, so the screen replay defence on Android rests on the challenge alone. The desktop app is a scaffold, and certified SBI device testing remains as next step. Thank you.</a:t>
             </a:r>
           </a:p>
         </p:txBody>
@@ -4140,14 +4140,14 @@
       </p:sp>
       <p:sp>
         <p:nvSpPr>
-          <p:cNvPr id="6" name="Production status chip"/>
+          <p:cNvPr id="6" name="Status chip"/>
           <p:cNvSpPr/>
           <p:nvPr/>
         </p:nvSpPr>
         <p:spPr>
           <a:xfrm>
             <a:off x="640080" y="5577840"/>
-            <a:ext cx="7132320" cy="530352"/>
+            <a:ext cx="3657600" cy="530352"/>
           </a:xfrm>
           <a:prstGeom prst="roundRect">
             <a:avLst>
@@ -4155,11 +4155,11 @@
             </a:avLst>
           </a:prstGeom>
           <a:solidFill>
-            <a:srgbClr val="E6F4EA"/>
+            <a:srgbClr val="E7EFF8"/>
           </a:solidFill>
           <a:ln w="22225">
             <a:solidFill>
-              <a:srgbClr val="1B6E3C"/>
+              <a:srgbClr val="1B4F8A"/>
             </a:solidFill>
           </a:ln>
           <a:effectLst/>
@@ -4188,13 +4188,13 @@
               </a:spcAft>
             </a:pPr>
             <a:r>
-              <a:rPr sz="1600" b="1" i="0">
-                <a:solidFill>
-                  <a:srgbClr val="1B6E3C"/>
-                </a:solidFill>
-                <a:latin typeface="Calibri"/>
-              </a:rPr>
-              <a:t>Production-Ready Engine · Verified on Hardware · ISO/IEC 30107-3 Aligned</a:t>
+              <a:rPr sz="1700" b="1" i="0">
+                <a:solidFill>
+                  <a:srgbClr val="1B4F8A"/>
+                </a:solidFill>
+                <a:latin typeface="Calibri"/>
+              </a:rPr>
+              <a:t>Evidence-first prototype</a:t>
             </a:r>
           </a:p>
         </p:txBody>
@@ -12202,7 +12202,7 @@
                 </a:solidFill>
                 <a:latin typeface="Calibri"/>
               </a:rPr>
-              <a:t>needs a light; not yet shown on real replays</a:t>
+              <a:t>needs a light; author test only, not a corpus</a:t>
             </a:r>
           </a:p>
         </p:txBody>
@@ -14287,7 +14287,7 @@
           <a:p>
             <a:pPr algn="l">
               <a:spcAft>
-                <a:spcPts val="500"/>
+                <a:spcPts val="400"/>
               </a:spcAft>
             </a:pPr>
             <a:r>
@@ -14303,7 +14303,7 @@
           <a:p>
             <a:pPr algn="l">
               <a:spcAft>
-                <a:spcPts val="500"/>
+                <a:spcPts val="400"/>
               </a:spcAft>
             </a:pPr>
             <a:r>
@@ -14328,7 +14328,7 @@
           <a:p>
             <a:pPr algn="l">
               <a:spcAft>
-                <a:spcPts val="500"/>
+                <a:spcPts val="400"/>
               </a:spcAft>
             </a:pPr>
             <a:r>
@@ -14338,13 +14338,13 @@
                 </a:solidFill>
                 <a:latin typeface="Calibri"/>
               </a:rPr>
-              <a:t>Hardware verified: physical Android phone &amp; webcam with OBS veto</a:t>
-            </a:r>
-          </a:p>
-          <a:p>
-            <a:pPr algn="l">
-              <a:spcAft>
-                <a:spcPts val="500"/>
+              <a:t>Hardware measured: models &amp; camera timed on one phone; OBS veto on Windows webcam list</a:t>
+            </a:r>
+          </a:p>
+          <a:p>
+            <a:pPr algn="l">
+              <a:spcAft>
+                <a:spcPts val="400"/>
               </a:spcAft>
             </a:pPr>
             <a:r>
@@ -14360,7 +14360,7 @@
           <a:p>
             <a:pPr algn="l">
               <a:spcAft>
-                <a:spcPts val="500"/>
+                <a:spcPts val="400"/>
               </a:spcAft>
             </a:pPr>
             <a:r>
@@ -14376,7 +14376,7 @@
           <a:p>
             <a:pPr algn="l">
               <a:spcAft>
-                <a:spcPts val="500"/>
+                <a:spcPts val="400"/>
               </a:spcAft>
             </a:pPr>
             <a:r>
@@ -14392,7 +14392,7 @@
           <a:p>
             <a:pPr algn="l">
               <a:spcAft>
-                <a:spcPts val="500"/>
+                <a:spcPts val="400"/>
               </a:spcAft>
             </a:pPr>
             <a:r>
@@ -14453,7 +14453,7 @@
           <a:p>
             <a:pPr algn="l">
               <a:spcAft>
-                <a:spcPts val="500"/>
+                <a:spcPts val="400"/>
               </a:spcAft>
             </a:pPr>
             <a:r>
@@ -14463,17 +14463,17 @@
                 </a:solidFill>
                 <a:latin typeface="Calibri"/>
               </a:rPr>
-              <a:t>Scientific Discipline &amp; Scope</a:t>
-            </a:r>
-          </a:p>
-          <a:p>
-            <a:pPr algn="l">
-              <a:spcAft>
-                <a:spcPts val="500"/>
-              </a:spcAft>
-            </a:pPr>
-            <a:r>
-              <a:rPr sz="1400" b="0" i="0">
+              <a:t>Scientific Discipline &amp; Limits</a:t>
+            </a:r>
+          </a:p>
+          <a:p>
+            <a:pPr algn="l">
+              <a:spcAft>
+                <a:spcPts val="400"/>
+              </a:spcAft>
+            </a:pPr>
+            <a:r>
+              <a:rPr sz="1300" b="0" i="0">
                 <a:solidFill>
                   <a:srgbClr val="14202E"/>
                 </a:solidFill>
@@ -14485,59 +14485,68 @@
           <a:p>
             <a:pPr algn="l">
               <a:spcAft>
-                <a:spcPts val="500"/>
-              </a:spcAft>
-            </a:pPr>
-            <a:r>
-              <a:rPr sz="1400" b="0" i="0">
+                <a:spcPts val="400"/>
+              </a:spcAft>
+            </a:pPr>
+            <a:r>
+              <a:rPr sz="1300" b="0" i="0">
                 <a:solidFill>
                   <a:srgbClr val="14202E"/>
                 </a:solidFill>
                 <a:latin typeface="Calibri"/>
               </a:rPr>
-              <a:t>Hardware scope: models &amp; camera timed on phone (350 ms median)</a:t>
-            </a:r>
-          </a:p>
-          <a:p>
-            <a:pPr algn="l">
-              <a:spcAft>
-                <a:spcPts val="500"/>
-              </a:spcAft>
-            </a:pPr>
-            <a:r>
-              <a:rPr sz="1400" b="0" i="0">
+              <a:t>Scaffold, not full Registration Client; no live certified SBI device session</a:t>
+            </a:r>
+          </a:p>
+          <a:p>
+            <a:pPr algn="l">
+              <a:spcAft>
+                <a:spcPts val="400"/>
+              </a:spcAft>
+            </a:pPr>
+            <a:r>
+              <a:rPr sz="1300" b="1" i="0">
                 <a:solidFill>
                   <a:srgbClr val="14202E"/>
                 </a:solidFill>
                 <a:latin typeface="Calibri"/>
               </a:rPr>
-              <a:t>MOSIP Integration: patch for registration-client + standalone scaffold</a:t>
-            </a:r>
-          </a:p>
-          <a:p>
-            <a:pPr algn="l">
-              <a:spcAft>
-                <a:spcPts val="500"/>
-              </a:spcAft>
-            </a:pPr>
-            <a:r>
-              <a:rPr sz="1400" b="0" i="0">
+              <a:t>Android replay limit: </a:t>
+            </a:r>
+            <a:r>
+              <a:rPr sz="1300" b="0" i="0">
                 <a:solidFill>
                   <a:srgbClr val="14202E"/>
                 </a:solidFill>
                 <a:latin typeface="Calibri"/>
               </a:rPr>
+              <a:t>passive model fooled by replay (0.98 score) and flash needs ≥ 3 fps (phone got 2.7–2.9 fps); replay defence rests on challenge alone.</a:t>
+            </a:r>
+          </a:p>
+          <a:p>
+            <a:pPr algn="l">
+              <a:spcAft>
+                <a:spcPts val="400"/>
+              </a:spcAft>
+            </a:pPr>
+            <a:r>
+              <a:rPr sz="1300" b="0" i="0">
+                <a:solidFill>
+                  <a:srgbClr val="14202E"/>
+                </a:solidFill>
+                <a:latin typeface="Calibri"/>
+              </a:rPr>
               <a:t>Inclusive UX: native Devanagari Hindi verified; accessibility profiles</a:t>
             </a:r>
           </a:p>
           <a:p>
             <a:pPr algn="l">
               <a:spcAft>
-                <a:spcPts val="500"/>
-              </a:spcAft>
-            </a:pPr>
-            <a:r>
-              <a:rPr sz="1400" b="1" i="0">
+                <a:spcPts val="400"/>
+              </a:spcAft>
+            </a:pPr>
+            <a:r>
+              <a:rPr sz="1300" b="1" i="0">
                 <a:solidFill>
                   <a:srgbClr val="14202E"/>
                 </a:solidFill>
@@ -14546,7 +14555,7 @@
               <a:t>Self-Red-Teaming: </a:t>
             </a:r>
             <a:r>
-              <a:rPr sz="1400" b="0" i="0">
+              <a:rPr sz="1300" b="0" i="0">
                 <a:solidFill>
                   <a:srgbClr val="14202E"/>
                 </a:solidFill>

</xml_diff>